<commit_message>
docs: ajout graphiques clés dans la présentation VitaIA
</commit_message>
<xml_diff>
--- a/docs/presentation_vitaIA.pptx
+++ b/docs/presentation_vitaIA.pptx
@@ -14,6 +14,7 @@
     <p:sldId id="262" r:id="rId8"/>
     <p:sldId id="263" r:id="rId9"/>
     <p:sldId id="264" r:id="rId10"/>
+    <p:sldId id="268" r:id="rId19"/>
     <p:sldId id="265" r:id="rId11"/>
     <p:sldId id="266" r:id="rId12"/>
     <p:sldId id="267" r:id="rId13"/>
@@ -4722,6 +4723,142 @@
 </p:sld>
 </file>
 
+<file path=ppt/slides/slide13.xml><?xml version="1.0" encoding="utf-8"?>
+<p:sld xmlns:a="http://schemas.openxmlformats.org/drawingml/2006/main" xmlns:r="http://schemas.openxmlformats.org/officeDocument/2006/relationships" xmlns:p="http://schemas.openxmlformats.org/presentationml/2006/main">
+  <p:cSld name="Importance des Variables">
+    <p:bg>
+      <p:bgPr>
+        <a:solidFill>
+          <a:srgbClr val="FFFFFF"/>
+        </a:solidFill>
+      </p:bgPr>
+    </p:bg>
+    <p:spTree>
+      <p:nvGrpSpPr>
+        <p:cNvPr id="1" name=""/>
+        <p:cNvGrpSpPr/>
+        <p:nvPr/>
+      </p:nvGrpSpPr>
+      <p:grpSpPr>
+        <a:xfrm>
+          <a:off x="0" y="0"/>
+          <a:ext cx="0" cy="0"/>
+          <a:chOff x="0" y="0"/>
+          <a:chExt cx="0" cy="0"/>
+        </a:xfrm>
+      </p:grpSpPr>
+      <p:sp>
+        <p:nvSpPr>
+          <p:cNvPr id="2" name="HeaderBar"/>
+          <p:cNvSpPr/>
+          <p:nvPr/>
+        </p:nvSpPr>
+        <p:spPr>
+          <a:xfrm>
+            <a:off x="0" y="0"/>
+            <a:ext cx="12192000" cy="1097280"/>
+          </a:xfrm>
+          <a:prstGeom prst="rect">
+            <a:avLst/>
+          </a:prstGeom>
+          <a:solidFill>
+            <a:srgbClr val="1E2761"/>
+          </a:solidFill>
+          <a:ln>
+            <a:noFill/>
+          </a:ln>
+        </p:spPr>
+        <p:txBody>
+          <a:bodyPr wrap="square" rtlCol="0" anchor="ctr"/>
+          <a:lstStyle/>
+          <a:p>
+            <a:pPr algn="ctr" indent="0" marL="0">
+              <a:buNone/>
+            </a:pPr>
+            <a:r>
+              <a:rPr lang="fr-FR" sz="2800" b="1" dirty="0">
+                <a:solidFill>
+                  <a:srgbClr val="FFFFFF"/>
+                </a:solidFill>
+                <a:latin typeface="Calibri" pitchFamily="34" charset="0"/>
+              </a:rPr>
+              <a:t>Importance des Variables</a:t>
+            </a:r>
+          </a:p>
+        </p:txBody>
+      </p:sp>
+      <p:pic>
+        <p:nvPicPr>
+          <p:cNvPr id="3" name="Image_FeatureImportance"/>
+          <p:cNvPicPr>
+            <a:picLocks noChangeAspect="1"/>
+          </p:cNvPicPr>
+          <p:nvPr/>
+        </p:nvPicPr>
+        <p:blipFill>
+          <a:blip r:embed="rId3"/>
+          <a:stretch>
+            <a:fillRect/>
+          </a:stretch>
+        </p:blipFill>
+        <p:spPr>
+          <a:xfrm>
+            <a:off x="1371600" y="1280160"/>
+            <a:ext cx="9144000" cy="5303520"/>
+          </a:xfrm>
+          <a:prstGeom prst="rect">
+            <a:avLst/>
+          </a:prstGeom>
+        </p:spPr>
+      </p:pic>
+      <p:sp>
+        <p:nvSpPr>
+          <p:cNvPr id="4" name="SpeakerBanner"/>
+          <p:cNvSpPr/>
+          <p:nvPr/>
+        </p:nvSpPr>
+        <p:spPr>
+          <a:xfrm>
+            <a:off x="0" y="6583680"/>
+            <a:ext cx="12192000" cy="274320"/>
+          </a:xfrm>
+          <a:prstGeom prst="rect">
+            <a:avLst/>
+          </a:prstGeom>
+          <a:solidFill>
+            <a:srgbClr val="1E2761"/>
+          </a:solidFill>
+          <a:ln>
+            <a:noFill/>
+          </a:ln>
+        </p:spPr>
+        <p:txBody>
+          <a:bodyPr wrap="square" rtlCol="0" anchor="ctr"/>
+          <a:lstStyle/>
+          <a:p>
+            <a:pPr algn="ctr" indent="0" marL="0">
+              <a:buNone/>
+            </a:pPr>
+            <a:r>
+              <a:rPr lang="fr-FR" sz="900" b="0" dirty="0">
+                <a:solidFill>
+                  <a:srgbClr val="FFFFFF"/>
+                </a:solidFill>
+                <a:latin typeface="Calibri" pitchFamily="34" charset="0"/>
+              </a:rPr>
+              <a:t>🎤 Hazem</a:t>
+            </a:r>
+          </a:p>
+        </p:txBody>
+      </p:sp>
+    </p:spTree>
+  </p:cSld>
+  <p:clrMapOvr>
+    <a:masterClrMapping/>
+  </p:clrMapOvr>
+</p:sld>
+</file>
+
 <file path=ppt/slides/slide2.xml><?xml version="1.0" encoding="utf-8"?>
 <p:sld xmlns:a="http://schemas.openxmlformats.org/drawingml/2006/main" xmlns:r="http://schemas.openxmlformats.org/officeDocument/2006/relationships" xmlns:p="http://schemas.openxmlformats.org/presentationml/2006/main">
   <p:cSld name="Slide 2">
@@ -8355,6 +8492,30 @@
           </a:p>
         </p:txBody>
       </p:sp>
+      <p:pic>
+        <p:nvPicPr>
+          <p:cNvPr id="28" name="Image_SMOTE"/>
+          <p:cNvPicPr>
+            <a:picLocks noChangeAspect="1"/>
+          </p:cNvPicPr>
+          <p:nvPr/>
+        </p:nvPicPr>
+        <p:blipFill>
+          <a:blip r:embed="rId3"/>
+          <a:stretch>
+            <a:fillRect/>
+          </a:stretch>
+        </p:blipFill>
+        <p:spPr>
+          <a:xfrm>
+            <a:off x="914400" y="3840480"/>
+            <a:ext cx="10058400" cy="2560320"/>
+          </a:xfrm>
+          <a:prstGeom prst="rect">
+            <a:avLst/>
+          </a:prstGeom>
+        </p:spPr>
+      </p:pic>
     </p:spTree>
   </p:cSld>
   <p:clrMapOvr>
@@ -10539,6 +10700,30 @@
           </a:p>
         </p:txBody>
       </p:sp>
+      <p:pic>
+        <p:nvPicPr>
+          <p:cNvPr id="32" name="Image_ComparModeles"/>
+          <p:cNvPicPr>
+            <a:picLocks noChangeAspect="1"/>
+          </p:cNvPicPr>
+          <p:nvPr/>
+        </p:nvPicPr>
+        <p:blipFill>
+          <a:blip r:embed="rId3"/>
+          <a:stretch>
+            <a:fillRect/>
+          </a:stretch>
+        </p:blipFill>
+        <p:spPr>
+          <a:xfrm>
+            <a:off x="1828800" y="4114800"/>
+            <a:ext cx="8229600" cy="2286000"/>
+          </a:xfrm>
+          <a:prstGeom prst="rect">
+            <a:avLst/>
+          </a:prstGeom>
+        </p:spPr>
+      </p:pic>
     </p:spTree>
   </p:cSld>
   <p:clrMapOvr>
@@ -12249,6 +12434,30 @@
           </a:p>
         </p:txBody>
       </p:sp>
+      <p:pic>
+        <p:nvPicPr>
+          <p:cNvPr id="54" name="Image_AblationRecap"/>
+          <p:cNvPicPr>
+            <a:picLocks noChangeAspect="1"/>
+          </p:cNvPicPr>
+          <p:nvPr/>
+        </p:nvPicPr>
+        <p:blipFill>
+          <a:blip r:embed="rId3"/>
+          <a:stretch>
+            <a:fillRect/>
+          </a:stretch>
+        </p:blipFill>
+        <p:spPr>
+          <a:xfrm>
+            <a:off x="6583680" y="1371600"/>
+            <a:ext cx="5303520" cy="5029200"/>
+          </a:xfrm>
+          <a:prstGeom prst="rect">
+            <a:avLst/>
+          </a:prstGeom>
+        </p:spPr>
+      </p:pic>
     </p:spTree>
   </p:cSld>
   <p:clrMapOvr>
@@ -13225,6 +13434,54 @@
           </a:p>
         </p:txBody>
       </p:sp>
+      <p:pic>
+        <p:nvPicPr>
+          <p:cNvPr id="29" name="Image_ConfusionMatrix"/>
+          <p:cNvPicPr>
+            <a:picLocks noChangeAspect="1"/>
+          </p:cNvPicPr>
+          <p:nvPr/>
+        </p:nvPicPr>
+        <p:blipFill>
+          <a:blip r:embed="rId3"/>
+          <a:stretch>
+            <a:fillRect/>
+          </a:stretch>
+        </p:blipFill>
+        <p:spPr>
+          <a:xfrm>
+            <a:off x="274320" y="3200400"/>
+            <a:ext cx="5486400" cy="3200400"/>
+          </a:xfrm>
+          <a:prstGeom prst="rect">
+            <a:avLst/>
+          </a:prstGeom>
+        </p:spPr>
+      </p:pic>
+      <p:pic>
+        <p:nvPicPr>
+          <p:cNvPr id="30" name="Image_ROCCurves"/>
+          <p:cNvPicPr>
+            <a:picLocks noChangeAspect="1"/>
+          </p:cNvPicPr>
+          <p:nvPr/>
+        </p:nvPicPr>
+        <p:blipFill>
+          <a:blip r:embed="rId4"/>
+          <a:stretch>
+            <a:fillRect/>
+          </a:stretch>
+        </p:blipFill>
+        <p:spPr>
+          <a:xfrm>
+            <a:off x="6217920" y="3200400"/>
+            <a:ext cx="5486400" cy="3200400"/>
+          </a:xfrm>
+          <a:prstGeom prst="rect">
+            <a:avLst/>
+          </a:prstGeom>
+        </p:spPr>
+      </p:pic>
     </p:spTree>
   </p:cSld>
   <p:clrMapOvr>

</xml_diff>

<commit_message>
docs: ajout slides détails ablation, matrices confusion et courbes apprentissage
</commit_message>
<xml_diff>
--- a/docs/presentation_vitaIA.pptx
+++ b/docs/presentation_vitaIA.pptx
@@ -13,6 +13,9 @@
     <p:sldId id="261" r:id="rId7"/>
     <p:sldId id="262" r:id="rId8"/>
     <p:sldId id="263" r:id="rId9"/>
+    <p:sldId id="269" r:id="rId20"/>
+    <p:sldId id="270" r:id="rId21"/>
+    <p:sldId id="271" r:id="rId22"/>
     <p:sldId id="264" r:id="rId10"/>
     <p:sldId id="268" r:id="rId19"/>
     <p:sldId id="265" r:id="rId11"/>
@@ -4848,6 +4851,779 @@
               </a:rPr>
               <a:t>🎤 Hazem</a:t>
             </a:r>
+          </a:p>
+        </p:txBody>
+      </p:sp>
+    </p:spTree>
+  </p:cSld>
+  <p:clrMapOvr>
+    <a:masterClrMapping/>
+  </p:clrMapOvr>
+</p:sld>
+</file>
+
+<file path=ppt/slides/slide14.xml><?xml version="1.0" encoding="utf-8"?>
+<p:sld xmlns:a="http://schemas.openxmlformats.org/drawingml/2006/main" xmlns:r="http://schemas.openxmlformats.org/officeDocument/2006/relationships" xmlns:p="http://schemas.openxmlformats.org/presentationml/2006/main">
+  <p:cSld name="Slide 14">
+    <p:bg>
+      <p:bgPr>
+        <a:solidFill>
+          <a:srgbClr val="FFFFFF"/>
+        </a:solidFill>
+      </p:bgPr>
+    </p:bg>
+    <p:spTree>
+      <p:nvGrpSpPr>
+        <p:cNvPr id="1" name=""/>
+        <p:cNvGrpSpPr/>
+        <p:nvPr/>
+      </p:nvGrpSpPr>
+      <p:grpSpPr>
+        <a:xfrm>
+          <a:off x="0" y="0"/>
+          <a:ext cx="0" cy="0"/>
+          <a:chOff x="0" y="0"/>
+          <a:chExt cx="0" cy="0"/>
+        </a:xfrm>
+      </p:grpSpPr>
+      <p:sp>
+        <p:nvSpPr>
+          <p:cNvPr id="2" name="Shape_Header"/>
+          <p:cNvSpPr/>
+          <p:nvPr/>
+        </p:nvSpPr>
+        <p:spPr>
+          <a:xfrm>
+            <a:off x="0" y="0"/>
+            <a:ext cx="12192000" cy="1005840"/>
+          </a:xfrm>
+          <a:prstGeom prst="rect">
+            <a:avLst/>
+          </a:prstGeom>
+          <a:solidFill>
+            <a:srgbClr val="1E2761"/>
+          </a:solidFill>
+          <a:ln w="12700">
+            <a:solidFill>
+              <a:srgbClr val="1E2761"/>
+            </a:solidFill>
+            <a:prstDash val="solid"/>
+          </a:ln>
+        </p:spPr>
+      </p:sp>
+      <p:sp>
+        <p:nvSpPr>
+          <p:cNvPr id="3" name="Text_Title"/>
+          <p:cNvSpPr/>
+          <p:nvPr/>
+        </p:nvSpPr>
+        <p:spPr>
+          <a:xfrm>
+            <a:off x="411480" y="0"/>
+            <a:ext cx="11365992" cy="1005840"/>
+          </a:xfrm>
+          <a:prstGeom prst="rect">
+            <a:avLst/>
+          </a:prstGeom>
+          <a:noFill/>
+          <a:ln/>
+        </p:spPr>
+        <p:txBody>
+          <a:bodyPr wrap="square" lIns="0" tIns="0" rIns="0" bIns="0" rtlCol="0" anchor="ctr"/>
+          <a:lstStyle/>
+          <a:p>
+            <a:pPr algn="l" indent="0" marL="0">
+              <a:buNone/>
+            </a:pPr>
+            <a:r>
+              <a:rPr lang="fr-FR" sz="2800" b="1" dirty="0">
+                <a:solidFill>
+                  <a:srgbClr val="FFFFFF"/>
+                </a:solidFill>
+                <a:latin typeface="Calibri" pitchFamily="34" charset="0"/>
+                <a:ea typeface="Calibri" pitchFamily="34" charset="-122"/>
+                <a:cs typeface="Calibri" pitchFamily="34" charset="-120"/>
+              </a:rPr>
+              <a:t>Détails de l’Ablation</a:t>
+            </a:r>
+            <a:endParaRPr lang="fr-FR" sz="2800" dirty="0"/>
+          </a:p>
+        </p:txBody>
+      </p:sp>
+      <p:pic>
+        <p:nvPicPr>
+          <p:cNvPr id="4" name="Image_Ablation1"/>
+          <p:cNvPicPr>
+            <a:picLocks noChangeAspect="1"/>
+          </p:cNvPicPr>
+          <p:nvPr/>
+        </p:nvPicPr>
+        <p:blipFill>
+          <a:blip r:embed="rId2"/>
+          <a:stretch>
+            <a:fillRect/>
+          </a:stretch>
+        </p:blipFill>
+        <p:spPr>
+          <a:xfrm>
+            <a:off x="274320" y="1188720"/>
+            <a:ext cx="5669280" cy="2560320"/>
+          </a:xfrm>
+          <a:prstGeom prst="rect">
+            <a:avLst/>
+          </a:prstGeom>
+        </p:spPr>
+      </p:pic>
+      <p:pic>
+        <p:nvPicPr>
+          <p:cNvPr id="5" name="Image_Ablation2"/>
+          <p:cNvPicPr>
+            <a:picLocks noChangeAspect="1"/>
+          </p:cNvPicPr>
+          <p:nvPr/>
+        </p:nvPicPr>
+        <p:blipFill>
+          <a:blip r:embed="rId3"/>
+          <a:stretch>
+            <a:fillRect/>
+          </a:stretch>
+        </p:blipFill>
+        <p:spPr>
+          <a:xfrm>
+            <a:off x="6217920" y="1188720"/>
+            <a:ext cx="5669280" cy="2560320"/>
+          </a:xfrm>
+          <a:prstGeom prst="rect">
+            <a:avLst/>
+          </a:prstGeom>
+        </p:spPr>
+      </p:pic>
+      <p:pic>
+        <p:nvPicPr>
+          <p:cNvPr id="6" name="Image_Ablation3"/>
+          <p:cNvPicPr>
+            <a:picLocks noChangeAspect="1"/>
+          </p:cNvPicPr>
+          <p:nvPr/>
+        </p:nvPicPr>
+        <p:blipFill>
+          <a:blip r:embed="rId4"/>
+          <a:stretch>
+            <a:fillRect/>
+          </a:stretch>
+        </p:blipFill>
+        <p:spPr>
+          <a:xfrm>
+            <a:off x="274320" y="3931920"/>
+            <a:ext cx="5669280" cy="2560320"/>
+          </a:xfrm>
+          <a:prstGeom prst="rect">
+            <a:avLst/>
+          </a:prstGeom>
+        </p:spPr>
+      </p:pic>
+      <p:pic>
+        <p:nvPicPr>
+          <p:cNvPr id="7" name="Image_Ablation4"/>
+          <p:cNvPicPr>
+            <a:picLocks noChangeAspect="1"/>
+          </p:cNvPicPr>
+          <p:nvPr/>
+        </p:nvPicPr>
+        <p:blipFill>
+          <a:blip r:embed="rId5"/>
+          <a:stretch>
+            <a:fillRect/>
+          </a:stretch>
+        </p:blipFill>
+        <p:spPr>
+          <a:xfrm>
+            <a:off x="6217920" y="3931920"/>
+            <a:ext cx="5669280" cy="2560320"/>
+          </a:xfrm>
+          <a:prstGeom prst="rect">
+            <a:avLst/>
+          </a:prstGeom>
+        </p:spPr>
+      </p:pic>
+      <p:sp>
+        <p:nvSpPr>
+          <p:cNvPr id="8" name="Caption1"/>
+          <p:cNvSpPr/>
+          <p:nvPr/>
+        </p:nvSpPr>
+        <p:spPr>
+          <a:xfrm>
+            <a:off x="274320" y="3749040"/>
+            <a:ext cx="5669280" cy="182880"/>
+          </a:xfrm>
+          <a:prstGeom prst="rect">
+            <a:avLst/>
+          </a:prstGeom>
+          <a:solidFill>
+            <a:srgbClr val="1E2761"/>
+          </a:solidFill>
+          <a:ln/>
+        </p:spPr>
+        <p:txBody>
+          <a:bodyPr wrap="square" lIns="0" tIns="0" rIns="0" bIns="0" rtlCol="0" anchor="ctr"/>
+          <a:lstStyle/>
+          <a:p>
+            <a:pPr algn="ctr" indent="0" marL="0">
+              <a:buNone/>
+            </a:pPr>
+            <a:r>
+              <a:rPr lang="fr-FR" sz="1200" dirty="0">
+                <a:solidFill>
+                  <a:srgbClr val="FFFFFF"/>
+                </a:solidFill>
+                <a:latin typeface="Calibri" pitchFamily="34" charset="0"/>
+                <a:ea typeface="Calibri" pitchFamily="34" charset="-122"/>
+                <a:cs typeface="Calibri" pitchFamily="34" charset="-120"/>
+              </a:rPr>
+              <a:t>1. Sans SMOTE</a:t>
+            </a:r>
+            <a:endParaRPr lang="fr-FR" sz="1200" dirty="0"/>
+          </a:p>
+        </p:txBody>
+      </p:sp>
+      <p:sp>
+        <p:nvSpPr>
+          <p:cNvPr id="9" name="Caption2"/>
+          <p:cNvSpPr/>
+          <p:nvPr/>
+        </p:nvSpPr>
+        <p:spPr>
+          <a:xfrm>
+            <a:off x="6217920" y="3749040"/>
+            <a:ext cx="5669280" cy="182880"/>
+          </a:xfrm>
+          <a:prstGeom prst="rect">
+            <a:avLst/>
+          </a:prstGeom>
+          <a:solidFill>
+            <a:srgbClr val="1E2761"/>
+          </a:solidFill>
+          <a:ln/>
+        </p:spPr>
+        <p:txBody>
+          <a:bodyPr wrap="square" lIns="0" tIns="0" rIns="0" bIns="0" rtlCol="0" anchor="ctr"/>
+          <a:lstStyle/>
+          <a:p>
+            <a:pPr algn="ctr" indent="0" marL="0">
+              <a:buNone/>
+            </a:pPr>
+            <a:r>
+              <a:rPr lang="fr-FR" sz="1200" dirty="0">
+                <a:solidFill>
+                  <a:srgbClr val="FFFFFF"/>
+                </a:solidFill>
+                <a:latin typeface="Calibri" pitchFamily="34" charset="0"/>
+                <a:ea typeface="Calibri" pitchFamily="34" charset="-122"/>
+                <a:cs typeface="Calibri" pitchFamily="34" charset="-120"/>
+              </a:rPr>
+              <a:t>2. Avec Lifestyle</a:t>
+            </a:r>
+            <a:endParaRPr lang="fr-FR" sz="1200" dirty="0"/>
+          </a:p>
+        </p:txBody>
+      </p:sp>
+      <p:sp>
+        <p:nvSpPr>
+          <p:cNvPr id="10" name="Caption3"/>
+          <p:cNvSpPr/>
+          <p:nvPr/>
+        </p:nvSpPr>
+        <p:spPr>
+          <a:xfrm>
+            <a:off x="274320" y="6492240"/>
+            <a:ext cx="5669280" cy="182880"/>
+          </a:xfrm>
+          <a:prstGeom prst="rect">
+            <a:avLst/>
+          </a:prstGeom>
+          <a:solidFill>
+            <a:srgbClr val="1E2761"/>
+          </a:solidFill>
+          <a:ln/>
+        </p:spPr>
+        <p:txBody>
+          <a:bodyPr wrap="square" lIns="0" tIns="0" rIns="0" bIns="0" rtlCol="0" anchor="ctr"/>
+          <a:lstStyle/>
+          <a:p>
+            <a:pPr algn="ctr" indent="0" marL="0">
+              <a:buNone/>
+            </a:pPr>
+            <a:r>
+              <a:rPr lang="fr-FR" sz="1200" dirty="0">
+                <a:solidFill>
+                  <a:srgbClr val="FFFFFF"/>
+                </a:solidFill>
+                <a:latin typeface="Calibri" pitchFamily="34" charset="0"/>
+                <a:ea typeface="Calibri" pitchFamily="34" charset="-122"/>
+                <a:cs typeface="Calibri" pitchFamily="34" charset="-120"/>
+              </a:rPr>
+              <a:t>3. Sans Biomarqueurs</a:t>
+            </a:r>
+            <a:endParaRPr lang="fr-FR" sz="1200" dirty="0"/>
+          </a:p>
+        </p:txBody>
+      </p:sp>
+      <p:sp>
+        <p:nvSpPr>
+          <p:cNvPr id="11" name="Caption4"/>
+          <p:cNvSpPr/>
+          <p:nvPr/>
+        </p:nvSpPr>
+        <p:spPr>
+          <a:xfrm>
+            <a:off x="6217920" y="6492240"/>
+            <a:ext cx="5669280" cy="182880"/>
+          </a:xfrm>
+          <a:prstGeom prst="rect">
+            <a:avLst/>
+          </a:prstGeom>
+          <a:solidFill>
+            <a:srgbClr val="1E2761"/>
+          </a:solidFill>
+          <a:ln/>
+        </p:spPr>
+        <p:txBody>
+          <a:bodyPr wrap="square" lIns="0" tIns="0" rIns="0" bIns="0" rtlCol="0" anchor="ctr"/>
+          <a:lstStyle/>
+          <a:p>
+            <a:pPr algn="ctr" indent="0" marL="0">
+              <a:buNone/>
+            </a:pPr>
+            <a:r>
+              <a:rPr lang="fr-FR" sz="1200" dirty="0">
+                <a:solidFill>
+                  <a:srgbClr val="FFFFFF"/>
+                </a:solidFill>
+                <a:latin typeface="Calibri" pitchFamily="34" charset="0"/>
+                <a:ea typeface="Calibri" pitchFamily="34" charset="-122"/>
+                <a:cs typeface="Calibri" pitchFamily="34" charset="-120"/>
+              </a:rPr>
+              <a:t>4. Sans Scaler</a:t>
+            </a:r>
+            <a:endParaRPr lang="fr-FR" sz="1200" dirty="0"/>
+          </a:p>
+        </p:txBody>
+      </p:sp>
+      <p:sp>
+        <p:nvSpPr>
+          <p:cNvPr id="12" name="Shape_SpeakerBanner"/>
+          <p:cNvSpPr/>
+          <p:nvPr/>
+        </p:nvSpPr>
+        <p:spPr>
+          <a:xfrm>
+            <a:off x="0" y="6675120"/>
+            <a:ext cx="12192000" cy="182880"/>
+          </a:xfrm>
+          <a:prstGeom prst="rect">
+            <a:avLst/>
+          </a:prstGeom>
+          <a:solidFill>
+            <a:srgbClr val="1E2761"/>
+          </a:solidFill>
+          <a:ln/>
+        </p:spPr>
+      </p:sp>
+      <p:sp>
+        <p:nvSpPr>
+          <p:cNvPr id="13" name="Text_Speaker"/>
+          <p:cNvSpPr/>
+          <p:nvPr/>
+        </p:nvSpPr>
+        <p:spPr>
+          <a:xfrm>
+            <a:off x="0" y="6675120"/>
+            <a:ext cx="12192000" cy="182880"/>
+          </a:xfrm>
+          <a:prstGeom prst="rect">
+            <a:avLst/>
+          </a:prstGeom>
+          <a:noFill/>
+          <a:ln/>
+        </p:spPr>
+        <p:txBody>
+          <a:bodyPr wrap="square" lIns="91440" tIns="0" rIns="0" bIns="0" rtlCol="0" anchor="ctr"/>
+          <a:lstStyle/>
+          <a:p>
+            <a:pPr algn="l" indent="0" marL="0">
+              <a:buNone/>
+            </a:pPr>
+            <a:r>
+              <a:rPr lang="fr-FR" sz="1000" dirty="0">
+                <a:solidFill>
+                  <a:srgbClr val="FFFFFF"/>
+                </a:solidFill>
+                <a:latin typeface="Calibri" pitchFamily="34" charset="0"/>
+                <a:ea typeface="Calibri" pitchFamily="34" charset="-122"/>
+                <a:cs typeface="Calibri" pitchFamily="34" charset="-120"/>
+              </a:rPr>
+              <a:t>🎤 Serdar</a:t>
+            </a:r>
+            <a:endParaRPr lang="fr-FR" sz="1000" dirty="0"/>
+          </a:p>
+        </p:txBody>
+      </p:sp>
+    </p:spTree>
+  </p:cSld>
+  <p:clrMapOvr>
+    <a:masterClrMapping/>
+  </p:clrMapOvr>
+</p:sld>
+</file>
+
+<file path=ppt/slides/slide15.xml><?xml version="1.0" encoding="utf-8"?>
+<p:sld xmlns:a="http://schemas.openxmlformats.org/drawingml/2006/main" xmlns:r="http://schemas.openxmlformats.org/officeDocument/2006/relationships" xmlns:p="http://schemas.openxmlformats.org/presentationml/2006/main">
+  <p:cSld name="Slide 15">
+    <p:bg>
+      <p:bgPr>
+        <a:solidFill>
+          <a:srgbClr val="FFFFFF"/>
+        </a:solidFill>
+      </p:bgPr>
+    </p:bg>
+    <p:spTree>
+      <p:nvGrpSpPr>
+        <p:cNvPr id="1" name=""/>
+        <p:cNvGrpSpPr/>
+        <p:nvPr/>
+      </p:nvGrpSpPr>
+      <p:grpSpPr>
+        <a:xfrm>
+          <a:off x="0" y="0"/>
+          <a:ext cx="0" cy="0"/>
+          <a:chOff x="0" y="0"/>
+          <a:chExt cx="0" cy="0"/>
+        </a:xfrm>
+      </p:grpSpPr>
+      <p:sp>
+        <p:nvSpPr>
+          <p:cNvPr id="2" name="Shape_Header"/>
+          <p:cNvSpPr/>
+          <p:nvPr/>
+        </p:nvSpPr>
+        <p:spPr>
+          <a:xfrm>
+            <a:off x="0" y="0"/>
+            <a:ext cx="12192000" cy="1005840"/>
+          </a:xfrm>
+          <a:prstGeom prst="rect">
+            <a:avLst/>
+          </a:prstGeom>
+          <a:solidFill>
+            <a:srgbClr val="1E2761"/>
+          </a:solidFill>
+          <a:ln w="12700">
+            <a:solidFill>
+              <a:srgbClr val="1E2761"/>
+            </a:solidFill>
+            <a:prstDash val="solid"/>
+          </a:ln>
+        </p:spPr>
+      </p:sp>
+      <p:sp>
+        <p:nvSpPr>
+          <p:cNvPr id="3" name="Text_Title"/>
+          <p:cNvSpPr/>
+          <p:nvPr/>
+        </p:nvSpPr>
+        <p:spPr>
+          <a:xfrm>
+            <a:off x="411480" y="0"/>
+            <a:ext cx="11365992" cy="1005840"/>
+          </a:xfrm>
+          <a:prstGeom prst="rect">
+            <a:avLst/>
+          </a:prstGeom>
+          <a:noFill/>
+          <a:ln/>
+        </p:spPr>
+        <p:txBody>
+          <a:bodyPr wrap="square" lIns="0" tIns="0" rIns="0" bIns="0" rtlCol="0" anchor="ctr"/>
+          <a:lstStyle/>
+          <a:p>
+            <a:pPr algn="l" indent="0" marL="0">
+              <a:buNone/>
+            </a:pPr>
+            <a:r>
+              <a:rPr lang="fr-FR" sz="2800" b="1" dirty="0">
+                <a:solidFill>
+                  <a:srgbClr val="FFFFFF"/>
+                </a:solidFill>
+                <a:latin typeface="Calibri" pitchFamily="34" charset="0"/>
+                <a:ea typeface="Calibri" pitchFamily="34" charset="-122"/>
+                <a:cs typeface="Calibri" pitchFamily="34" charset="-120"/>
+              </a:rPr>
+              <a:t>Matrices de Confusion</a:t>
+            </a:r>
+            <a:endParaRPr lang="fr-FR" sz="2800" dirty="0"/>
+          </a:p>
+        </p:txBody>
+      </p:sp>
+      <p:pic>
+        <p:nvPicPr>
+          <p:cNvPr id="4" name="Image_MatricesConfusion"/>
+          <p:cNvPicPr>
+            <a:picLocks noChangeAspect="1"/>
+          </p:cNvPicPr>
+          <p:nvPr/>
+        </p:nvPicPr>
+        <p:blipFill>
+          <a:blip r:embed="rId2"/>
+          <a:stretch>
+            <a:fillRect/>
+          </a:stretch>
+        </p:blipFill>
+        <p:spPr>
+          <a:xfrm>
+            <a:off x="914400" y="1188720"/>
+            <a:ext cx="10058400" cy="5303520"/>
+          </a:xfrm>
+          <a:prstGeom prst="rect">
+            <a:avLst/>
+          </a:prstGeom>
+        </p:spPr>
+      </p:pic>
+      <p:sp>
+        <p:nvSpPr>
+          <p:cNvPr id="5" name="Shape_SpeakerBanner"/>
+          <p:cNvSpPr/>
+          <p:nvPr/>
+        </p:nvSpPr>
+        <p:spPr>
+          <a:xfrm>
+            <a:off x="0" y="6675120"/>
+            <a:ext cx="12192000" cy="182880"/>
+          </a:xfrm>
+          <a:prstGeom prst="rect">
+            <a:avLst/>
+          </a:prstGeom>
+          <a:solidFill>
+            <a:srgbClr val="1E2761"/>
+          </a:solidFill>
+          <a:ln/>
+        </p:spPr>
+      </p:sp>
+      <p:sp>
+        <p:nvSpPr>
+          <p:cNvPr id="6" name="Text_Speaker"/>
+          <p:cNvSpPr/>
+          <p:nvPr/>
+        </p:nvSpPr>
+        <p:spPr>
+          <a:xfrm>
+            <a:off x="0" y="6675120"/>
+            <a:ext cx="12192000" cy="182880"/>
+          </a:xfrm>
+          <a:prstGeom prst="rect">
+            <a:avLst/>
+          </a:prstGeom>
+          <a:noFill/>
+          <a:ln/>
+        </p:spPr>
+        <p:txBody>
+          <a:bodyPr wrap="square" lIns="91440" tIns="0" rIns="0" bIns="0" rtlCol="0" anchor="ctr"/>
+          <a:lstStyle/>
+          <a:p>
+            <a:pPr algn="l" indent="0" marL="0">
+              <a:buNone/>
+            </a:pPr>
+            <a:r>
+              <a:rPr lang="fr-FR" sz="1000" dirty="0">
+                <a:solidFill>
+                  <a:srgbClr val="FFFFFF"/>
+                </a:solidFill>
+                <a:latin typeface="Calibri" pitchFamily="34" charset="0"/>
+                <a:ea typeface="Calibri" pitchFamily="34" charset="-122"/>
+                <a:cs typeface="Calibri" pitchFamily="34" charset="-120"/>
+              </a:rPr>
+              <a:t>🎤 Serdar</a:t>
+            </a:r>
+            <a:endParaRPr lang="fr-FR" sz="1000" dirty="0"/>
+          </a:p>
+        </p:txBody>
+      </p:sp>
+    </p:spTree>
+  </p:cSld>
+  <p:clrMapOvr>
+    <a:masterClrMapping/>
+  </p:clrMapOvr>
+</p:sld>
+</file>
+
+<file path=ppt/slides/slide16.xml><?xml version="1.0" encoding="utf-8"?>
+<p:sld xmlns:a="http://schemas.openxmlformats.org/drawingml/2006/main" xmlns:r="http://schemas.openxmlformats.org/officeDocument/2006/relationships" xmlns:p="http://schemas.openxmlformats.org/presentationml/2006/main">
+  <p:cSld name="Slide 16">
+    <p:bg>
+      <p:bgPr>
+        <a:solidFill>
+          <a:srgbClr val="FFFFFF"/>
+        </a:solidFill>
+      </p:bgPr>
+    </p:bg>
+    <p:spTree>
+      <p:nvGrpSpPr>
+        <p:cNvPr id="1" name=""/>
+        <p:cNvGrpSpPr/>
+        <p:nvPr/>
+      </p:nvGrpSpPr>
+      <p:grpSpPr>
+        <a:xfrm>
+          <a:off x="0" y="0"/>
+          <a:ext cx="0" cy="0"/>
+          <a:chOff x="0" y="0"/>
+          <a:chExt cx="0" cy="0"/>
+        </a:xfrm>
+      </p:grpSpPr>
+      <p:sp>
+        <p:nvSpPr>
+          <p:cNvPr id="2" name="Shape_Header"/>
+          <p:cNvSpPr/>
+          <p:nvPr/>
+        </p:nvSpPr>
+        <p:spPr>
+          <a:xfrm>
+            <a:off x="0" y="0"/>
+            <a:ext cx="12192000" cy="1005840"/>
+          </a:xfrm>
+          <a:prstGeom prst="rect">
+            <a:avLst/>
+          </a:prstGeom>
+          <a:solidFill>
+            <a:srgbClr val="1E2761"/>
+          </a:solidFill>
+          <a:ln w="12700">
+            <a:solidFill>
+              <a:srgbClr val="1E2761"/>
+            </a:solidFill>
+            <a:prstDash val="solid"/>
+          </a:ln>
+        </p:spPr>
+      </p:sp>
+      <p:sp>
+        <p:nvSpPr>
+          <p:cNvPr id="3" name="Text_Title"/>
+          <p:cNvSpPr/>
+          <p:nvPr/>
+        </p:nvSpPr>
+        <p:spPr>
+          <a:xfrm>
+            <a:off x="411480" y="0"/>
+            <a:ext cx="11365992" cy="1005840"/>
+          </a:xfrm>
+          <a:prstGeom prst="rect">
+            <a:avLst/>
+          </a:prstGeom>
+          <a:noFill/>
+          <a:ln/>
+        </p:spPr>
+        <p:txBody>
+          <a:bodyPr wrap="square" lIns="0" tIns="0" rIns="0" bIns="0" rtlCol="0" anchor="ctr"/>
+          <a:lstStyle/>
+          <a:p>
+            <a:pPr algn="l" indent="0" marL="0">
+              <a:buNone/>
+            </a:pPr>
+            <a:r>
+              <a:rPr lang="fr-FR" sz="2800" b="1" dirty="0">
+                <a:solidFill>
+                  <a:srgbClr val="FFFFFF"/>
+                </a:solidFill>
+                <a:latin typeface="Calibri" pitchFamily="34" charset="0"/>
+                <a:ea typeface="Calibri" pitchFamily="34" charset="-122"/>
+                <a:cs typeface="Calibri" pitchFamily="34" charset="-120"/>
+              </a:rPr>
+              <a:t>Courbes d’Apprentissage</a:t>
+            </a:r>
+            <a:endParaRPr lang="fr-FR" sz="2800" dirty="0"/>
+          </a:p>
+        </p:txBody>
+      </p:sp>
+      <p:pic>
+        <p:nvPicPr>
+          <p:cNvPr id="4" name="Image_LearningCurves"/>
+          <p:cNvPicPr>
+            <a:picLocks noChangeAspect="1"/>
+          </p:cNvPicPr>
+          <p:nvPr/>
+        </p:nvPicPr>
+        <p:blipFill>
+          <a:blip r:embed="rId2"/>
+          <a:stretch>
+            <a:fillRect/>
+          </a:stretch>
+        </p:blipFill>
+        <p:spPr>
+          <a:xfrm>
+            <a:off x="1371600" y="1188720"/>
+            <a:ext cx="9144000" cy="5303520"/>
+          </a:xfrm>
+          <a:prstGeom prst="rect">
+            <a:avLst/>
+          </a:prstGeom>
+        </p:spPr>
+      </p:pic>
+      <p:sp>
+        <p:nvSpPr>
+          <p:cNvPr id="5" name="Shape_SpeakerBanner"/>
+          <p:cNvSpPr/>
+          <p:nvPr/>
+        </p:nvSpPr>
+        <p:spPr>
+          <a:xfrm>
+            <a:off x="0" y="6675120"/>
+            <a:ext cx="12192000" cy="182880"/>
+          </a:xfrm>
+          <a:prstGeom prst="rect">
+            <a:avLst/>
+          </a:prstGeom>
+          <a:solidFill>
+            <a:srgbClr val="1E2761"/>
+          </a:solidFill>
+          <a:ln/>
+        </p:spPr>
+      </p:sp>
+      <p:sp>
+        <p:nvSpPr>
+          <p:cNvPr id="6" name="Text_Speaker"/>
+          <p:cNvSpPr/>
+          <p:nvPr/>
+        </p:nvSpPr>
+        <p:spPr>
+          <a:xfrm>
+            <a:off x="0" y="6675120"/>
+            <a:ext cx="12192000" cy="182880"/>
+          </a:xfrm>
+          <a:prstGeom prst="rect">
+            <a:avLst/>
+          </a:prstGeom>
+          <a:noFill/>
+          <a:ln/>
+        </p:spPr>
+        <p:txBody>
+          <a:bodyPr wrap="square" lIns="91440" tIns="0" rIns="0" bIns="0" rtlCol="0" anchor="ctr"/>
+          <a:lstStyle/>
+          <a:p>
+            <a:pPr algn="l" indent="0" marL="0">
+              <a:buNone/>
+            </a:pPr>
+            <a:r>
+              <a:rPr lang="fr-FR" sz="1000" dirty="0">
+                <a:solidFill>
+                  <a:srgbClr val="FFFFFF"/>
+                </a:solidFill>
+                <a:latin typeface="Calibri" pitchFamily="34" charset="0"/>
+                <a:ea typeface="Calibri" pitchFamily="34" charset="-122"/>
+                <a:cs typeface="Calibri" pitchFamily="34" charset="-120"/>
+              </a:rPr>
+              <a:t>🎤 Serdar</a:t>
+            </a:r>
+            <a:endParaRPr lang="fr-FR" sz="1000" dirty="0"/>
           </a:p>
         </p:txBody>
       </p:sp>

</xml_diff>